<commit_message>
Remove mentions of other brands from the Disney presentation
Update the Disney brand equity presentation by removing all references to competitor brands and media companies, focusing solely on The Walt Disney Company.

Replit-Commit-Author: Agent
Replit-Commit-Session-Id: d1af01ac-c843-4bff-a7a9-fedef4198273
Replit-Commit-Checkpoint-Type: full_checkpoint
Replit-Commit-Event-Id: 18c632b8-6ebe-4041-924e-82c6b26b1749
Replit-Helium-Checkpoint-Created: true
</commit_message>
<xml_diff>
--- a/Factor_Analysis_Disney_Presentation.pptx
+++ b/Factor_Analysis_Disney_Presentation.pptx
@@ -3204,7 +3204,7 @@
               </a:defRPr>
             </a:pPr>
             <a:r>
-              <a:t>Brand Equity Analysis: Disney &amp; Media Companies</a:t>
+              <a:t>Brand Equity Analysis: The Walt Disney Company</a:t>
             </a:r>
           </a:p>
         </p:txBody>
@@ -7716,7 +7716,7 @@
               </a:defRPr>
             </a:pPr>
             <a:r>
-              <a:t>Implications for Media Companies:</a:t>
+              <a:t>Implications for Disney:</a:t>
             </a:r>
           </a:p>
           <a:p>
@@ -7800,7 +7800,7 @@
               </a:defRPr>
             </a:pPr>
             <a:r>
-              <a:t>For NBCUniversal:</a:t>
+              <a:t>Strategic Recommendations:</a:t>
             </a:r>
           </a:p>
           <a:p>
@@ -7815,7 +7815,7 @@
               </a:defRPr>
             </a:pPr>
             <a:r>
-              <a:t>Strengthen brand image through franchise experiences</a:t>
+              <a:t>Brand awareness alone is insufficient for Disney</a:t>
             </a:r>
           </a:p>
           <a:p>
@@ -7830,7 +7830,7 @@
               </a:defRPr>
             </a:pPr>
             <a:r>
-              <a:t>Develop Peacock loyalty features</a:t>
+              <a:t>Focus on emotional engagement over awareness</a:t>
             </a:r>
           </a:p>
           <a:p>
@@ -7845,7 +7845,7 @@
               </a:defRPr>
             </a:pPr>
             <a:r>
-              <a:t>Universal Studios immersive attractions</a:t>
+              <a:t>Loyalty drives long-term brand equity</a:t>
             </a:r>
           </a:p>
           <a:p>
@@ -7859,65 +7859,8 @@
                 </a:solidFill>
               </a:defRPr>
             </a:pPr>
-          </a:p>
-          <a:p>
-            <a:pPr>
-              <a:spcAft>
-                <a:spcPts val="600"/>
-              </a:spcAft>
-              <a:defRPr sz="1400" b="1">
-                <a:solidFill>
-                  <a:srgbClr val="00468C"/>
-                </a:solidFill>
-              </a:defRPr>
-            </a:pPr>
-            <a:r>
-              <a:t>For All Media Companies:</a:t>
-            </a:r>
-          </a:p>
-          <a:p>
-            <a:pPr>
-              <a:spcAft>
-                <a:spcPts val="600"/>
-              </a:spcAft>
-              <a:defRPr sz="1200">
-                <a:solidFill>
-                  <a:srgbClr val="323232"/>
-                </a:solidFill>
-              </a:defRPr>
-            </a:pPr>
-            <a:r>
-              <a:t>Brand awareness alone is insufficient</a:t>
-            </a:r>
-          </a:p>
-          <a:p>
-            <a:pPr>
-              <a:spcAft>
-                <a:spcPts val="600"/>
-              </a:spcAft>
-              <a:defRPr sz="1200">
-                <a:solidFill>
-                  <a:srgbClr val="323232"/>
-                </a:solidFill>
-              </a:defRPr>
-            </a:pPr>
-            <a:r>
-              <a:t>Focus on emotional engagement &gt; awareness</a:t>
-            </a:r>
-          </a:p>
-          <a:p>
-            <a:pPr>
-              <a:spcAft>
-                <a:spcPts val="600"/>
-              </a:spcAft>
-              <a:defRPr sz="1200">
-                <a:solidFill>
-                  <a:srgbClr val="323232"/>
-                </a:solidFill>
-              </a:defRPr>
-            </a:pPr>
-            <a:r>
-              <a:t>Loyalty drives long-term brand equity</a:t>
+            <a:r>
+              <a:t>Theme park experiences reinforce brand image</a:t>
             </a:r>
           </a:p>
         </p:txBody>
@@ -10188,7 +10131,7 @@
               </a:defRPr>
             </a:pPr>
             <a:r>
-              <a:t>Results are context-specific and may not generalize to other entertainment companies like NBCUniversal</a:t>
+              <a:t>Results are context-specific to Disney and may not generalize to other industries</a:t>
             </a:r>
           </a:p>
         </p:txBody>
@@ -10406,7 +10349,7 @@
               </a:defRPr>
             </a:pPr>
             <a:r>
-              <a:t>Include competitor comparison: Disney vs. NBCUniversal vs. Warner Bros.</a:t>
+              <a:t>Include comparison across different Disney business segments</a:t>
             </a:r>
           </a:p>
           <a:p>
@@ -10831,7 +10774,7 @@
               </a:defRPr>
             </a:pPr>
             <a:r>
-              <a:t>For entertainment companies like Disney and NBCUniversal, investing in brand image and customer loyalty yields stronger brand equity than increasing awareness alone</a:t>
+              <a:t>For Disney, investing in brand image and customer loyalty yields stronger brand equity than increasing awareness alone</a:t>
             </a:r>
           </a:p>
         </p:txBody>
@@ -11423,7 +11366,7 @@
               </a:defRPr>
             </a:pPr>
             <a:r>
-              <a:t>• The entertainment industry (Disney, NBCUniversal, Warner Bros.) manages complex brand portfolios across multiple business segments</a:t>
+              <a:t>• The Walt Disney Company manages a complex brand portfolio across multiple business segments</a:t>
             </a:r>
           </a:p>
           <a:p>
@@ -13503,7 +13446,7 @@
               </a:defRPr>
             </a:pPr>
             <a:r>
-              <a:t>Studio Entertainment (Pixar, Marvel, Lucasfilm)</a:t>
+              <a:t>Studio Entertainment</a:t>
             </a:r>
           </a:p>
           <a:p>
@@ -13518,7 +13461,7 @@
               </a:defRPr>
             </a:pPr>
             <a:r>
-              <a:t>Direct-to-Consumer (Disney+, Hulu)</a:t>
+              <a:t>Direct-to-Consumer (Disney+)</a:t>
             </a:r>
           </a:p>
           <a:p>
@@ -13545,7 +13488,7 @@
               </a:defRPr>
             </a:pPr>
             <a:r>
-              <a:t>Competitors:</a:t>
+              <a:t>Why Disney?</a:t>
             </a:r>
           </a:p>
           <a:p>
@@ -13560,7 +13503,7 @@
               </a:defRPr>
             </a:pPr>
             <a:r>
-              <a:t>NBCUniversal (Comcast) - Peacock, Universal Studios</a:t>
+              <a:t>Brand value: $57.0 billion (Brand Finance, 2022)</a:t>
             </a:r>
           </a:p>
           <a:p>
@@ -13575,7 +13518,7 @@
               </a:defRPr>
             </a:pPr>
             <a:r>
-              <a:t>Warner Bros. Discovery - HBO, DC Comics</a:t>
+              <a:t>Global presence across 6 continents</a:t>
             </a:r>
           </a:p>
           <a:p>
@@ -13590,22 +13533,7 @@
               </a:defRPr>
             </a:pPr>
             <a:r>
-              <a:t>Netflix, Amazon Prime Video</a:t>
-            </a:r>
-          </a:p>
-          <a:p>
-            <a:pPr>
-              <a:spcAft>
-                <a:spcPts val="600"/>
-              </a:spcAft>
-              <a:defRPr sz="1300">
-                <a:solidFill>
-                  <a:srgbClr val="323232"/>
-                </a:solidFill>
-              </a:defRPr>
-            </a:pPr>
-            <a:r>
-              <a:t>Paramount Global - CBS, MTV</a:t>
+              <a:t>Nearly 100 years of brand heritage</a:t>
             </a:r>
           </a:p>
         </p:txBody>

</xml_diff>